<commit_message>
Flyer: clarify membership header, 9pt fine print, document locked rules
- Rail header BUNDLE WITH TOTAL -> BUNDLE + MY BEST BUY TOTAL, so the
  $6,099.97 clearly includes the membership (vs $5,899.98 merchandise)
- Disclaimers 8pt -> 9pt for phone / Teams readability
- README: locked design rules for the weekly template

Co-Authored-By: Claude Opus 5.5 <noreply@anthropic.com>
Claude-Session: https://claude.ai/code/session_01Xard8nPJ55MfNtw9Q5q6Uk
</commit_message>
<xml_diff>
--- a/LG_Best_Buy_83G6_2xM7_Flyer.pptx
+++ b/LG_Best_Buy_83G6_2xM7_Flyer.pptx
@@ -1844,7 +1844,7 @@
               <a:buNone/>
             </a:pPr>
             <a:r>
-              <a:rPr lang="en-US" sz="1300" b="1" spc="300" kern="0" dirty="0">
+              <a:rPr lang="en-US" sz="1250" b="1" spc="100" kern="0" dirty="0">
                 <a:solidFill>
                   <a:srgbClr val="FF5A7E"/>
                 </a:solidFill>
@@ -1852,9 +1852,9 @@
                 <a:ea typeface="Calibri" pitchFamily="34" charset="-122"/>
                 <a:cs typeface="Calibri" pitchFamily="34" charset="-120"/>
               </a:rPr>
-              <a:t>BUNDLE WITH TOTAL</a:t>
-            </a:r>
-            <a:endParaRPr lang="en-US" sz="1300" dirty="0"/>
+              <a:t>BUNDLE + MY BEST BUY TOTAL</a:t>
+            </a:r>
+            <a:endParaRPr lang="en-US" sz="1250" dirty="0"/>
           </a:p>
         </p:txBody>
       </p:sp>
@@ -2439,8 +2439,8 @@
         </p:nvSpPr>
         <p:spPr>
           <a:xfrm>
-            <a:off x="457200" y="6336792"/>
-            <a:ext cx="11277295" cy="411480"/>
+            <a:off x="457200" y="6309360"/>
+            <a:ext cx="11277295" cy="457200"/>
           </a:xfrm>
           <a:prstGeom prst="rect">
             <a:avLst/>
@@ -2459,7 +2459,7 @@
               <a:buNone/>
             </a:pPr>
             <a:r>
-              <a:rPr lang="en-US" sz="800" dirty="0">
+              <a:rPr lang="en-US" sz="900" dirty="0">
                 <a:solidFill>
                   <a:srgbClr val="8C8C9A"/>
                 </a:solidFill>
@@ -2469,7 +2469,7 @@
               </a:rPr>
               <a:t>Prices and offers subject to change. Confirm current cart pricing, free M7 promotional eligibility, membership, financing eligibility and installation eligibility before presenting.</a:t>
             </a:r>
-            <a:endParaRPr lang="en-US" sz="800" dirty="0"/>
+            <a:endParaRPr lang="en-US" sz="900" dirty="0"/>
           </a:p>
           <a:p>
             <a:pPr indent="0" marL="0">
@@ -2479,7 +2479,7 @@
               <a:buNone/>
             </a:pPr>
             <a:r>
-              <a:rPr lang="en-US" sz="800" dirty="0">
+              <a:rPr lang="en-US" sz="900" dirty="0">
                 <a:solidFill>
                   <a:srgbClr val="8C8C9A"/>
                 </a:solidFill>
@@ -2489,7 +2489,7 @@
               </a:rPr>
               <a:t>*Illustration: $6,099.97 ÷ 24 ≈ $254.17. Full-purchase eligibility and credit approval required. No interest if paid in full within 24 months.</a:t>
             </a:r>
-            <a:endParaRPr lang="en-US" sz="800" dirty="0"/>
+            <a:endParaRPr lang="en-US" sz="900" dirty="0"/>
           </a:p>
           <a:p>
             <a:pPr indent="0" marL="0">
@@ -2499,7 +2499,7 @@
               <a:buNone/>
             </a:pPr>
             <a:r>
-              <a:rPr lang="en-US" sz="800" dirty="0">
+              <a:rPr lang="en-US" sz="900" dirty="0">
                 <a:solidFill>
                   <a:srgbClr val="8C8C9A"/>
                 </a:solidFill>
@@ -2509,7 +2509,7 @@
               </a:rPr>
               <a:t>Otherwise, interest is charged from the purchase date. Minimum monthly payments required. †Confirm 83" G6 eligibility, installation scope and current offer dates.</a:t>
             </a:r>
-            <a:endParaRPr lang="en-US" sz="800" dirty="0"/>
+            <a:endParaRPr lang="en-US" sz="900" dirty="0"/>
           </a:p>
         </p:txBody>
       </p:sp>

</xml_diff>